<commit_message>
second slide deck on parsing
</commit_message>
<xml_diff>
--- a/Functional Programming/exercises-1-2.pptx
+++ b/Functional Programming/exercises-1-2.pptx
@@ -4,6 +4,9 @@
   <p:sldMasterIdLst>
     <p:sldMasterId id="2147483648" r:id="rId1"/>
   </p:sldMasterIdLst>
+  <p:notesMasterIdLst>
+    <p:notesMasterId r:id="rId13"/>
+  </p:notesMasterIdLst>
   <p:sldIdLst>
     <p:sldId id="256" r:id="rId2"/>
     <p:sldId id="257" r:id="rId3"/>
@@ -17,9 +20,6 @@
     <p:sldId id="265" r:id="rId11"/>
     <p:sldId id="266" r:id="rId12"/>
   </p:sldIdLst>
-  <p:notesMasterIdLst>
-    <p:notesMasterId r:id="rId13"/>
-  </p:notesMasterIdLst>
   <p:sldSz cx="12192000" cy="6858000"/>
   <p:notesSz cx="6858000" cy="12192000"/>
   <p:defaultTextStyle>
@@ -114,6 +114,11 @@
       </a:defRPr>
     </a:lvl9pPr>
   </p:defaultTextStyle>
+  <p:extLst>
+    <p:ext uri="{EFAFB233-063F-42B5-8137-9DF3F51BA10A}">
+      <p15:sldGuideLst xmlns:p15="http://schemas.microsoft.com/office/powerpoint/2012/main"/>
+    </p:ext>
+  </p:extLst>
 </p:presentation>
 </file>
 
@@ -139,234 +144,10 @@
           <a:chExt cx="0" cy="0"/>
         </a:xfrm>
       </p:grpSpPr>
-      <p:sp>
-        <p:nvSpPr>
-          <p:cNvPr id="2" name="Header Placeholder 1"/>
-          <p:cNvSpPr>
-            <a:spLocks noGrp="1"/>
-          </p:cNvSpPr>
-          <p:nvPr>
-            <p:ph type="hdr" sz="quarter"/>
-          </p:nvPr>
-        </p:nvSpPr>
-        <p:spPr>
-          <a:xfrm>
-            <a:off x="0" y="0"/>
-            <a:ext cx="2971800" cy="458788"/>
-          </a:xfrm>
-          <a:prstGeom prst="rect">
-            <a:avLst/>
-          </a:prstGeom>
-        </p:spPr>
-        <p:txBody>
-          <a:bodyPr vert="horz" lIns="91440" tIns="45720" rIns="91440" bIns="45720" rtlCol="0"/>
-          <a:lstStyle>
-            <a:lvl1pPr algn="l">
-              <a:defRPr sz="1200"/>
-            </a:lvl1pPr>
-          </a:lstStyle>
-          <a:p>
-            <a:endParaRPr lang="en-US"/>
-          </a:p>
-        </p:txBody>
-      </p:sp>
-      <p:sp>
-        <p:nvSpPr>
-          <p:cNvPr id="3" name="Date Placeholder 2"/>
-          <p:cNvSpPr>
-            <a:spLocks noGrp="1"/>
-          </p:cNvSpPr>
-          <p:nvPr>
-            <p:ph type="dt" idx="1"/>
-          </p:nvPr>
-        </p:nvSpPr>
-        <p:spPr>
-          <a:xfrm>
-            <a:off x="3884613" y="0"/>
-            <a:ext cx="2971800" cy="458788"/>
-          </a:xfrm>
-          <a:prstGeom prst="rect">
-            <a:avLst/>
-          </a:prstGeom>
-        </p:spPr>
-        <p:txBody>
-          <a:bodyPr vert="horz" lIns="91440" tIns="45720" rIns="91440" bIns="45720" rtlCol="0"/>
-          <a:lstStyle>
-            <a:lvl1pPr algn="r">
-              <a:defRPr sz="1200"/>
-            </a:lvl1pPr>
-          </a:lstStyle>
-          <a:p>
-            <a:fld id="{5282F153-3F37-0F45-9E97-73ACFA13230C}" type="datetimeFigureOut">
-              <a:rPr lang="en-US"/>
-              <a:t>7/23/19</a:t>
-            </a:fld>
-            <a:endParaRPr lang="en-US"/>
-          </a:p>
-        </p:txBody>
-      </p:sp>
-      <p:sp>
-        <p:nvSpPr>
-          <p:cNvPr id="4" name="Slide Image Placeholder 3"/>
-          <p:cNvSpPr>
-            <a:spLocks noGrp="1" noRot="1" noChangeAspect="1"/>
-          </p:cNvSpPr>
-          <p:nvPr>
-            <p:ph type="sldImg" idx="2"/>
-          </p:nvPr>
-        </p:nvSpPr>
-        <p:spPr>
-          <a:xfrm>
-            <a:off x="685800" y="1143000"/>
-            <a:ext cx="5486400" cy="3086100"/>
-          </a:xfrm>
-          <a:prstGeom prst="rect">
-            <a:avLst/>
-          </a:prstGeom>
-          <a:noFill/>
-          <a:ln w="12700">
-            <a:solidFill>
-              <a:prstClr val="black"/>
-            </a:solidFill>
-          </a:ln>
-        </p:spPr>
-        <p:txBody>
-          <a:bodyPr vert="horz" lIns="91440" tIns="45720" rIns="91440" bIns="45720" rtlCol="0" anchor="ctr"/>
-          <a:lstStyle/>
-          <a:p>
-            <a:endParaRPr lang="en-US"/>
-          </a:p>
-        </p:txBody>
-      </p:sp>
-      <p:sp>
-        <p:nvSpPr>
-          <p:cNvPr id="5" name="Notes Placeholder 4"/>
-          <p:cNvSpPr>
-            <a:spLocks noGrp="1"/>
-          </p:cNvSpPr>
-          <p:nvPr>
-            <p:ph type="body" sz="quarter" idx="3"/>
-          </p:nvPr>
-        </p:nvSpPr>
-        <p:spPr>
-          <a:xfrm>
-            <a:off x="685800" y="4400550"/>
-            <a:ext cx="5486400" cy="3600450"/>
-          </a:xfrm>
-          <a:prstGeom prst="rect">
-            <a:avLst/>
-          </a:prstGeom>
-        </p:spPr>
-        <p:txBody>
-          <a:bodyPr vert="horz" lIns="91440" tIns="45720" rIns="91440" bIns="45720" rtlCol="0"/>
-          <a:lstStyle/>
-          <a:p>
-            <a:pPr lvl="0"/>
-            <a:r>
-              <a:rPr lang="en-US"/>
-              <a:t>Click to edit Master text styles</a:t>
-            </a:r>
-          </a:p>
-          <a:p>
-            <a:pPr lvl="1"/>
-            <a:r>
-              <a:rPr lang="en-US"/>
-              <a:t>Second level</a:t>
-            </a:r>
-          </a:p>
-          <a:p>
-            <a:pPr lvl="2"/>
-            <a:r>
-              <a:rPr lang="en-US"/>
-              <a:t>Third level</a:t>
-            </a:r>
-          </a:p>
-          <a:p>
-            <a:pPr lvl="3"/>
-            <a:r>
-              <a:rPr lang="en-US"/>
-              <a:t>Fourth level</a:t>
-            </a:r>
-          </a:p>
-          <a:p>
-            <a:pPr lvl="4"/>
-            <a:r>
-              <a:rPr lang="en-US"/>
-              <a:t>Fifth level</a:t>
-            </a:r>
-          </a:p>
-        </p:txBody>
-      </p:sp>
-      <p:sp>
-        <p:nvSpPr>
-          <p:cNvPr id="6" name="Footer Placeholder 5"/>
-          <p:cNvSpPr>
-            <a:spLocks noGrp="1"/>
-          </p:cNvSpPr>
-          <p:nvPr>
-            <p:ph type="ftr" sz="quarter" idx="4"/>
-          </p:nvPr>
-        </p:nvSpPr>
-        <p:spPr>
-          <a:xfrm>
-            <a:off x="0" y="8685213"/>
-            <a:ext cx="2971800" cy="458787"/>
-          </a:xfrm>
-          <a:prstGeom prst="rect">
-            <a:avLst/>
-          </a:prstGeom>
-        </p:spPr>
-        <p:txBody>
-          <a:bodyPr vert="horz" lIns="91440" tIns="45720" rIns="91440" bIns="45720" rtlCol="0" anchor="b"/>
-          <a:lstStyle>
-            <a:lvl1pPr algn="l">
-              <a:defRPr sz="1200"/>
-            </a:lvl1pPr>
-          </a:lstStyle>
-          <a:p>
-            <a:endParaRPr lang="en-US"/>
-          </a:p>
-        </p:txBody>
-      </p:sp>
-      <p:sp>
-        <p:nvSpPr>
-          <p:cNvPr id="7" name="Slide Number Placeholder 6"/>
-          <p:cNvSpPr>
-            <a:spLocks noGrp="1"/>
-          </p:cNvSpPr>
-          <p:nvPr>
-            <p:ph type="sldNum" sz="quarter" idx="5"/>
-          </p:nvPr>
-        </p:nvSpPr>
-        <p:spPr>
-          <a:xfrm>
-            <a:off x="3884613" y="8685213"/>
-            <a:ext cx="2971800" cy="458787"/>
-          </a:xfrm>
-          <a:prstGeom prst="rect">
-            <a:avLst/>
-          </a:prstGeom>
-        </p:spPr>
-        <p:txBody>
-          <a:bodyPr vert="horz" lIns="91440" tIns="45720" rIns="91440" bIns="45720" rtlCol="0" anchor="b"/>
-          <a:lstStyle>
-            <a:lvl1pPr algn="r">
-              <a:defRPr sz="1200"/>
-            </a:lvl1pPr>
-          </a:lstStyle>
-          <a:p>
-            <a:fld id="{CE5E9CC1-C706-0F49-92D6-E571CC5EEA8F}" type="slidenum">
-              <a:rPr lang="en-US"/>
-              <a:t>‹#›</a:t>
-            </a:fld>
-            <a:endParaRPr lang="en-US"/>
-          </a:p>
-        </p:txBody>
-      </p:sp>
     </p:spTree>
     <p:extLst>
       <p:ext uri="{BB962C8B-B14F-4D97-AF65-F5344CB8AC3E}">
-        <p14:creationId xmlns:p14="http://schemas.microsoft.com/office/powerpoint/2010/main" val="1024086991"/>
+        <p14:creationId xmlns:p14="http://schemas.microsoft.com/office/powerpoint/2010/main" val="3794177141"/>
       </p:ext>
     </p:extLst>
   </p:cSld>
@@ -510,10 +291,6 @@
           <a:bodyPr/>
           <a:lstStyle/>
           <a:p>
-            <a:r>
-              <a:rPr lang="en-US" dirty="0"/>
-              <a:t/>
-            </a:r>
             <a:endParaRPr lang="en-US" dirty="0"/>
           </a:p>
         </p:txBody>
@@ -598,10 +375,6 @@
           <a:bodyPr/>
           <a:lstStyle/>
           <a:p>
-            <a:r>
-              <a:rPr lang="en-US" dirty="0"/>
-              <a:t/>
-            </a:r>
             <a:endParaRPr lang="en-US" dirty="0"/>
           </a:p>
         </p:txBody>
@@ -686,10 +459,6 @@
           <a:bodyPr/>
           <a:lstStyle/>
           <a:p>
-            <a:r>
-              <a:rPr lang="en-US" dirty="0"/>
-              <a:t/>
-            </a:r>
             <a:endParaRPr lang="en-US" dirty="0"/>
           </a:p>
         </p:txBody>
@@ -774,10 +543,6 @@
           <a:bodyPr/>
           <a:lstStyle/>
           <a:p>
-            <a:r>
-              <a:rPr lang="en-US" dirty="0"/>
-              <a:t/>
-            </a:r>
             <a:endParaRPr lang="en-US" dirty="0"/>
           </a:p>
         </p:txBody>
@@ -862,10 +627,6 @@
           <a:bodyPr/>
           <a:lstStyle/>
           <a:p>
-            <a:r>
-              <a:rPr lang="en-US" dirty="0"/>
-              <a:t/>
-            </a:r>
             <a:endParaRPr lang="en-US" dirty="0"/>
           </a:p>
         </p:txBody>
@@ -950,10 +711,6 @@
           <a:bodyPr/>
           <a:lstStyle/>
           <a:p>
-            <a:r>
-              <a:rPr lang="en-US" dirty="0"/>
-              <a:t/>
-            </a:r>
             <a:endParaRPr lang="en-US" dirty="0"/>
           </a:p>
         </p:txBody>
@@ -1038,10 +795,6 @@
           <a:bodyPr/>
           <a:lstStyle/>
           <a:p>
-            <a:r>
-              <a:rPr lang="en-US" dirty="0"/>
-              <a:t/>
-            </a:r>
             <a:endParaRPr lang="en-US" dirty="0"/>
           </a:p>
         </p:txBody>
@@ -1126,10 +879,6 @@
           <a:bodyPr/>
           <a:lstStyle/>
           <a:p>
-            <a:r>
-              <a:rPr lang="en-US" dirty="0"/>
-              <a:t/>
-            </a:r>
             <a:endParaRPr lang="en-US" dirty="0"/>
           </a:p>
         </p:txBody>
@@ -1214,10 +963,6 @@
           <a:bodyPr/>
           <a:lstStyle/>
           <a:p>
-            <a:r>
-              <a:rPr lang="en-US" dirty="0"/>
-              <a:t/>
-            </a:r>
             <a:endParaRPr lang="en-US" dirty="0"/>
           </a:p>
         </p:txBody>
@@ -1302,10 +1047,6 @@
           <a:bodyPr/>
           <a:lstStyle/>
           <a:p>
-            <a:r>
-              <a:rPr lang="en-US" dirty="0"/>
-              <a:t/>
-            </a:r>
             <a:endParaRPr lang="en-US" dirty="0"/>
           </a:p>
         </p:txBody>
@@ -1390,10 +1131,6 @@
           <a:bodyPr/>
           <a:lstStyle/>
           <a:p>
-            <a:r>
-              <a:rPr lang="en-US" dirty="0"/>
-              <a:t/>
-            </a:r>
             <a:endParaRPr lang="en-US" dirty="0"/>
           </a:p>
         </p:txBody>
@@ -1467,6 +1204,11 @@
 <file path=ppt/slideMasters/slideMaster1.xml><?xml version="1.0" encoding="utf-8"?>
 <p:sldMaster xmlns:a="http://schemas.openxmlformats.org/drawingml/2006/main" xmlns:r="http://schemas.openxmlformats.org/officeDocument/2006/relationships" xmlns:p="http://schemas.openxmlformats.org/presentationml/2006/main">
   <p:cSld>
+    <p:bg>
+      <p:bgRef idx="1001">
+        <a:schemeClr val="bg1"/>
+      </p:bgRef>
+    </p:bg>
     <p:spTree>
       <p:nvGrpSpPr>
         <p:cNvPr id="1" name=""/>
@@ -1749,6 +1491,7 @@
         <a:solidFill>
           <a:srgbClr val="1E3A5F"/>
         </a:solidFill>
+        <a:effectLst/>
       </p:bgPr>
     </p:bg>
     <p:spTree>
@@ -1786,7 +1529,7 @@
           <a:bodyPr wrap="square" rtlCol="0" anchor="ctr"/>
           <a:lstStyle/>
           <a:p>
-            <a:pPr algn="ctr" indent="0" marL="0">
+            <a:pPr marL="0" indent="0" algn="ctr">
               <a:buNone/>
             </a:pPr>
             <a:r>
@@ -1822,7 +1565,7 @@
           <a:bodyPr wrap="square" rtlCol="0" anchor="ctr"/>
           <a:lstStyle/>
           <a:p>
-            <a:pPr algn="ctr" indent="0" marL="0">
+            <a:pPr marL="0" indent="0" algn="ctr">
               <a:buNone/>
             </a:pPr>
             <a:r>
@@ -1861,6 +1604,13 @@
             <a:prstDash val="solid"/>
           </a:ln>
         </p:spPr>
+        <p:txBody>
+          <a:bodyPr/>
+          <a:lstStyle/>
+          <a:p>
+            <a:endParaRPr lang="en-US"/>
+          </a:p>
+        </p:txBody>
       </p:sp>
       <p:sp>
         <p:nvSpPr>
@@ -1883,7 +1633,7 @@
           <a:bodyPr wrap="square" rtlCol="0" anchor="ctr"/>
           <a:lstStyle/>
           <a:p>
-            <a:pPr algn="ctr" indent="0" marL="0">
+            <a:pPr marL="0" indent="0" algn="ctr">
               <a:buNone/>
             </a:pPr>
             <a:r>
@@ -1914,6 +1664,7 @@
         <a:solidFill>
           <a:srgbClr val="F8F9FA"/>
         </a:solidFill>
+        <a:effectLst/>
       </p:bgPr>
     </p:bg>
     <p:spTree>
@@ -1954,6 +1705,13 @@
             <a:prstDash val="solid"/>
           </a:ln>
         </p:spPr>
+        <p:txBody>
+          <a:bodyPr/>
+          <a:lstStyle/>
+          <a:p>
+            <a:endParaRPr lang="en-US"/>
+          </a:p>
+        </p:txBody>
       </p:sp>
       <p:sp>
         <p:nvSpPr>
@@ -1976,7 +1734,7 @@
           <a:bodyPr wrap="square" lIns="0" tIns="0" rIns="0" bIns="0" rtlCol="0" anchor="ctr"/>
           <a:lstStyle/>
           <a:p>
-            <a:pPr indent="0" marL="0">
+            <a:pPr marL="0" indent="0">
               <a:buNone/>
             </a:pPr>
             <a:r>
@@ -2015,6 +1773,13 @@
             <a:prstDash val="solid"/>
           </a:ln>
         </p:spPr>
+        <p:txBody>
+          <a:bodyPr/>
+          <a:lstStyle/>
+          <a:p>
+            <a:endParaRPr lang="en-US"/>
+          </a:p>
+        </p:txBody>
       </p:sp>
       <p:sp>
         <p:nvSpPr>
@@ -2037,7 +1802,7 @@
           <a:bodyPr wrap="square" rtlCol="0" anchor="t"/>
           <a:lstStyle/>
           <a:p>
-            <a:pPr indent="0" marL="0">
+            <a:pPr marL="0" indent="0">
               <a:buNone/>
             </a:pPr>
             <a:r>
@@ -2054,7 +1819,7 @@
             <a:endParaRPr lang="en-US" sz="2000" dirty="0"/>
           </a:p>
           <a:p>
-            <a:pPr indent="0" marL="0">
+            <a:pPr marL="0" indent="0">
               <a:buNone/>
             </a:pPr>
             <a:r>
@@ -2071,7 +1836,7 @@
             <a:endParaRPr lang="en-US" sz="2000" dirty="0"/>
           </a:p>
           <a:p>
-            <a:pPr indent="0" marL="0">
+            <a:pPr marL="0" indent="0">
               <a:buNone/>
             </a:pPr>
             <a:r>
@@ -2088,7 +1853,7 @@
             <a:endParaRPr lang="en-US" sz="2000" dirty="0"/>
           </a:p>
           <a:p>
-            <a:pPr indent="0" marL="0">
+            <a:pPr marL="0" indent="0">
               <a:buNone/>
             </a:pPr>
             <a:r>
@@ -2105,7 +1870,7 @@
             <a:endParaRPr lang="en-US" sz="2000" dirty="0"/>
           </a:p>
           <a:p>
-            <a:pPr indent="0" marL="0">
+            <a:pPr marL="0" indent="0">
               <a:buNone/>
             </a:pPr>
             <a:r>
@@ -2122,7 +1887,7 @@
             <a:endParaRPr lang="en-US" sz="2000" dirty="0"/>
           </a:p>
           <a:p>
-            <a:pPr indent="0" marL="0">
+            <a:pPr marL="0" indent="0">
               <a:buNone/>
             </a:pPr>
             <a:r>
@@ -2139,7 +1904,7 @@
             <a:endParaRPr lang="en-US" sz="2000" dirty="0"/>
           </a:p>
           <a:p>
-            <a:pPr indent="0" marL="0">
+            <a:pPr marL="0" indent="0">
               <a:buNone/>
             </a:pPr>
             <a:r>
@@ -2179,6 +1944,13 @@
             <a:prstDash val="dash"/>
           </a:ln>
         </p:spPr>
+        <p:txBody>
+          <a:bodyPr/>
+          <a:lstStyle/>
+          <a:p>
+            <a:endParaRPr lang="en-US"/>
+          </a:p>
+        </p:txBody>
       </p:sp>
       <p:sp>
         <p:nvSpPr>
@@ -2201,7 +1973,7 @@
           <a:bodyPr wrap="square" rtlCol="0" anchor="ctr"/>
           <a:lstStyle/>
           <a:p>
-            <a:pPr indent="0" marL="0">
+            <a:pPr marL="0" indent="0">
               <a:buNone/>
             </a:pPr>
             <a:r>
@@ -2238,6 +2010,13 @@
             <a:prstDash val="dash"/>
           </a:ln>
         </p:spPr>
+        <p:txBody>
+          <a:bodyPr/>
+          <a:lstStyle/>
+          <a:p>
+            <a:endParaRPr lang="en-US"/>
+          </a:p>
+        </p:txBody>
       </p:sp>
       <p:sp>
         <p:nvSpPr>
@@ -2260,7 +2039,7 @@
           <a:bodyPr wrap="square" rtlCol="0" anchor="ctr"/>
           <a:lstStyle/>
           <a:p>
-            <a:pPr indent="0" marL="0">
+            <a:pPr marL="0" indent="0">
               <a:buNone/>
             </a:pPr>
             <a:r>
@@ -2297,6 +2076,13 @@
             <a:prstDash val="dash"/>
           </a:ln>
         </p:spPr>
+        <p:txBody>
+          <a:bodyPr/>
+          <a:lstStyle/>
+          <a:p>
+            <a:endParaRPr lang="en-US"/>
+          </a:p>
+        </p:txBody>
       </p:sp>
       <p:sp>
         <p:nvSpPr>
@@ -2319,7 +2105,7 @@
           <a:bodyPr wrap="square" rtlCol="0" anchor="ctr"/>
           <a:lstStyle/>
           <a:p>
-            <a:pPr indent="0" marL="0">
+            <a:pPr marL="0" indent="0">
               <a:buNone/>
             </a:pPr>
             <a:r>
@@ -2355,7 +2141,7 @@
           <a:bodyPr wrap="square" rtlCol="0" anchor="ctr"/>
           <a:lstStyle/>
           <a:p>
-            <a:pPr indent="0" marL="0">
+            <a:pPr marL="0" indent="0">
               <a:buNone/>
             </a:pPr>
             <a:r>
@@ -2394,6 +2180,13 @@
             <a:prstDash val="solid"/>
           </a:ln>
         </p:spPr>
+        <p:txBody>
+          <a:bodyPr/>
+          <a:lstStyle/>
+          <a:p>
+            <a:endParaRPr lang="en-US"/>
+          </a:p>
+        </p:txBody>
       </p:sp>
       <p:sp>
         <p:nvSpPr>
@@ -2416,7 +2209,7 @@
           <a:bodyPr wrap="square" rtlCol="0" anchor="t"/>
           <a:lstStyle/>
           <a:p>
-            <a:pPr indent="0" marL="0">
+            <a:pPr marL="0" indent="0">
               <a:buNone/>
             </a:pPr>
             <a:r>
@@ -2433,7 +2226,7 @@
             <a:endParaRPr lang="en-US" sz="1500" dirty="0"/>
           </a:p>
           <a:p>
-            <a:pPr indent="0" marL="0">
+            <a:pPr marL="0" indent="0">
               <a:buNone/>
             </a:pPr>
             <a:r>
@@ -2467,6 +2260,7 @@
         <a:solidFill>
           <a:srgbClr val="F8F9FA"/>
         </a:solidFill>
+        <a:effectLst/>
       </p:bgPr>
     </p:bg>
     <p:spTree>
@@ -2507,6 +2301,13 @@
             <a:prstDash val="solid"/>
           </a:ln>
         </p:spPr>
+        <p:txBody>
+          <a:bodyPr/>
+          <a:lstStyle/>
+          <a:p>
+            <a:endParaRPr lang="en-US"/>
+          </a:p>
+        </p:txBody>
       </p:sp>
       <p:sp>
         <p:nvSpPr>
@@ -2529,7 +2330,7 @@
           <a:bodyPr wrap="square" lIns="0" tIns="0" rIns="0" bIns="0" rtlCol="0" anchor="ctr"/>
           <a:lstStyle/>
           <a:p>
-            <a:pPr indent="0" marL="0">
+            <a:pPr marL="0" indent="0">
               <a:buNone/>
             </a:pPr>
             <a:r>
@@ -2565,7 +2366,7 @@
           <a:bodyPr wrap="square" rtlCol="0" anchor="ctr"/>
           <a:lstStyle/>
           <a:p>
-            <a:pPr indent="0" marL="0">
+            <a:pPr marL="0" indent="0">
               <a:buNone/>
             </a:pPr>
             <a:r>
@@ -2577,9 +2378,6 @@
               <a:t>Exercise 1 — fmap for IO
 </a:t>
             </a:r>
-            <a:pPr indent="0" marL="0">
-              <a:buNone/>
-            </a:pPr>
             <a:r>
               <a:rPr lang="en-US" sz="1700" dirty="0">
                 <a:solidFill>
@@ -2588,9 +2386,6 @@
               </a:rPr>
               <a:t>Use </a:t>
             </a:r>
-            <a:pPr indent="0" marL="0">
-              <a:buNone/>
-            </a:pPr>
             <a:r>
               <a:rPr lang="en-US" sz="1700" b="1" dirty="0">
                 <a:solidFill>
@@ -2602,9 +2397,6 @@
               </a:rPr>
               <a:t>do</a:t>
             </a:r>
-            <a:pPr indent="0" marL="0">
-              <a:buNone/>
-            </a:pPr>
             <a:r>
               <a:rPr lang="en-US" sz="1700" dirty="0">
                 <a:solidFill>
@@ -2613,9 +2405,6 @@
               </a:rPr>
               <a:t> to run the IO action, then apply the function and </a:t>
             </a:r>
-            <a:pPr indent="0" marL="0">
-              <a:buNone/>
-            </a:pPr>
             <a:r>
               <a:rPr lang="en-US" sz="1700" b="1" dirty="0">
                 <a:solidFill>
@@ -2627,9 +2416,6 @@
               </a:rPr>
               <a:t>return</a:t>
             </a:r>
-            <a:pPr indent="0" marL="0">
-              <a:buNone/>
-            </a:pPr>
             <a:r>
               <a:rPr lang="en-US" sz="1700" dirty="0">
                 <a:solidFill>
@@ -2639,9 +2425,6 @@
               <a:t> the result. This is just the Functor pattern lifted to IO.
 </a:t>
             </a:r>
-            <a:pPr indent="0" marL="0">
-              <a:buNone/>
-            </a:pPr>
             <a:r>
               <a:rPr lang="en-US" sz="2000" b="1" dirty="0">
                 <a:solidFill>
@@ -2651,9 +2434,6 @@
               <a:t>Exercise 2 — repeat
 </a:t>
             </a:r>
-            <a:pPr indent="0" marL="0">
-              <a:buNone/>
-            </a:pPr>
             <a:r>
               <a:rPr lang="en-US" sz="1700" dirty="0">
                 <a:solidFill>
@@ -2662,9 +2442,6 @@
               </a:rPr>
               <a:t>Use recursion: run the test, and if </a:t>
             </a:r>
-            <a:pPr indent="0" marL="0">
-              <a:buNone/>
-            </a:pPr>
             <a:r>
               <a:rPr lang="en-US" sz="1700" b="1" dirty="0">
                 <a:solidFill>
@@ -2676,9 +2453,6 @@
               </a:rPr>
               <a:t>True</a:t>
             </a:r>
-            <a:pPr indent="0" marL="0">
-              <a:buNone/>
-            </a:pPr>
             <a:r>
               <a:rPr lang="en-US" sz="1700" dirty="0">
                 <a:solidFill>
@@ -2687,9 +2461,6 @@
               </a:rPr>
               <a:t> stop with </a:t>
             </a:r>
-            <a:pPr indent="0" marL="0">
-              <a:buNone/>
-            </a:pPr>
             <a:r>
               <a:rPr lang="en-US" sz="1700" b="1" dirty="0">
                 <a:solidFill>
@@ -2701,9 +2472,6 @@
               </a:rPr>
               <a:t>return ()</a:t>
             </a:r>
-            <a:pPr indent="0" marL="0">
-              <a:buNone/>
-            </a:pPr>
             <a:r>
               <a:rPr lang="en-US" sz="1700" dirty="0">
                 <a:solidFill>
@@ -2712,9 +2480,6 @@
               </a:rPr>
               <a:t>; if </a:t>
             </a:r>
-            <a:pPr indent="0" marL="0">
-              <a:buNone/>
-            </a:pPr>
             <a:r>
               <a:rPr lang="en-US" sz="1700" b="1" dirty="0">
                 <a:solidFill>
@@ -2726,9 +2491,6 @@
               </a:rPr>
               <a:t>False</a:t>
             </a:r>
-            <a:pPr indent="0" marL="0">
-              <a:buNone/>
-            </a:pPr>
             <a:r>
               <a:rPr lang="en-US" sz="1700" dirty="0">
                 <a:solidFill>
@@ -2765,6 +2527,13 @@
             <a:prstDash val="solid"/>
           </a:ln>
         </p:spPr>
+        <p:txBody>
+          <a:bodyPr/>
+          <a:lstStyle/>
+          <a:p>
+            <a:endParaRPr lang="en-US"/>
+          </a:p>
+        </p:txBody>
       </p:sp>
       <p:sp>
         <p:nvSpPr>
@@ -2787,7 +2556,7 @@
           <a:bodyPr wrap="square" rtlCol="0" anchor="ctr"/>
           <a:lstStyle/>
           <a:p>
-            <a:pPr indent="0" marL="0">
+            <a:pPr marL="0" indent="0">
               <a:buNone/>
             </a:pPr>
             <a:r>
@@ -2823,7 +2592,7 @@
           <a:bodyPr wrap="square" rtlCol="0" anchor="ctr"/>
           <a:lstStyle/>
           <a:p>
-            <a:pPr indent="0" marL="0">
+            <a:pPr marL="0" indent="0">
               <a:buNone/>
             </a:pPr>
             <a:r>
@@ -2840,7 +2609,7 @@
             <a:endParaRPr lang="en-US" sz="1400" dirty="0"/>
           </a:p>
           <a:p>
-            <a:pPr indent="0" marL="0">
+            <a:pPr marL="0" indent="0">
               <a:buNone/>
             </a:pPr>
             <a:r>
@@ -2854,7 +2623,7 @@
             <a:endParaRPr lang="en-US" sz="1400" dirty="0"/>
           </a:p>
           <a:p>
-            <a:pPr indent="0" marL="0">
+            <a:pPr marL="0" indent="0">
               <a:buNone/>
             </a:pPr>
             <a:r>
@@ -2871,7 +2640,7 @@
             <a:endParaRPr lang="en-US" sz="1400" dirty="0"/>
           </a:p>
           <a:p>
-            <a:pPr indent="0" marL="0">
+            <a:pPr marL="0" indent="0">
               <a:buNone/>
             </a:pPr>
             <a:r>
@@ -2902,6 +2671,7 @@
         <a:solidFill>
           <a:srgbClr val="2E86AB"/>
         </a:solidFill>
+        <a:effectLst/>
       </p:bgPr>
     </p:bg>
     <p:spTree>
@@ -2939,7 +2709,7 @@
           <a:bodyPr wrap="square" rtlCol="0" anchor="ctr"/>
           <a:lstStyle/>
           <a:p>
-            <a:pPr algn="ctr" indent="0" marL="0">
+            <a:pPr marL="0" indent="0" algn="ctr">
               <a:buNone/>
             </a:pPr>
             <a:r>
@@ -2975,7 +2745,7 @@
           <a:bodyPr wrap="square" rtlCol="0" anchor="ctr"/>
           <a:lstStyle/>
           <a:p>
-            <a:pPr algn="ctr" indent="0" marL="0">
+            <a:pPr marL="0" indent="0" algn="ctr">
               <a:buNone/>
             </a:pPr>
             <a:r>
@@ -3006,6 +2776,7 @@
         <a:solidFill>
           <a:srgbClr val="F8F9FA"/>
         </a:solidFill>
+        <a:effectLst/>
       </p:bgPr>
     </p:bg>
     <p:spTree>
@@ -3046,6 +2817,13 @@
             <a:prstDash val="solid"/>
           </a:ln>
         </p:spPr>
+        <p:txBody>
+          <a:bodyPr/>
+          <a:lstStyle/>
+          <a:p>
+            <a:endParaRPr lang="en-US"/>
+          </a:p>
+        </p:txBody>
       </p:sp>
       <p:sp>
         <p:nvSpPr>
@@ -3068,7 +2846,7 @@
           <a:bodyPr wrap="square" lIns="0" tIns="0" rIns="0" bIns="0" rtlCol="0" anchor="ctr"/>
           <a:lstStyle/>
           <a:p>
-            <a:pPr indent="0" marL="0">
+            <a:pPr marL="0" indent="0">
               <a:buNone/>
             </a:pPr>
             <a:r>
@@ -3104,7 +2882,7 @@
           <a:bodyPr wrap="square" rtlCol="0" anchor="ctr"/>
           <a:lstStyle/>
           <a:p>
-            <a:pPr indent="0" marL="0">
+            <a:pPr marL="0" indent="0">
               <a:buNone/>
             </a:pPr>
             <a:r>
@@ -3140,7 +2918,7 @@
           <a:bodyPr wrap="square" rtlCol="0" anchor="ctr"/>
           <a:lstStyle/>
           <a:p>
-            <a:pPr indent="0" marL="0">
+            <a:pPr marL="0" indent="0">
               <a:buNone/>
             </a:pPr>
             <a:r>
@@ -3179,6 +2957,13 @@
             <a:prstDash val="solid"/>
           </a:ln>
         </p:spPr>
+        <p:txBody>
+          <a:bodyPr/>
+          <a:lstStyle/>
+          <a:p>
+            <a:endParaRPr lang="en-US"/>
+          </a:p>
+        </p:txBody>
       </p:sp>
       <p:sp>
         <p:nvSpPr>
@@ -3201,7 +2986,7 @@
           <a:bodyPr wrap="square" rtlCol="0" anchor="t"/>
           <a:lstStyle/>
           <a:p>
-            <a:pPr indent="0" marL="0">
+            <a:pPr marL="0" indent="0">
               <a:buNone/>
             </a:pPr>
             <a:r>
@@ -3218,7 +3003,7 @@
             <a:endParaRPr lang="en-US" sz="1700" dirty="0"/>
           </a:p>
           <a:p>
-            <a:pPr indent="0" marL="0">
+            <a:pPr marL="0" indent="0">
               <a:buNone/>
             </a:pPr>
             <a:r>
@@ -3257,7 +3042,7 @@
           <a:bodyPr wrap="square" rtlCol="0" anchor="ctr"/>
           <a:lstStyle/>
           <a:p>
-            <a:pPr indent="0" marL="0">
+            <a:pPr marL="0" indent="0">
               <a:buNone/>
             </a:pPr>
             <a:r>
@@ -3296,6 +3081,13 @@
             <a:prstDash val="solid"/>
           </a:ln>
         </p:spPr>
+        <p:txBody>
+          <a:bodyPr/>
+          <a:lstStyle/>
+          <a:p>
+            <a:endParaRPr lang="en-US"/>
+          </a:p>
+        </p:txBody>
       </p:sp>
       <p:sp>
         <p:nvSpPr>
@@ -3318,7 +3110,7 @@
           <a:bodyPr wrap="square" rtlCol="0" anchor="t"/>
           <a:lstStyle/>
           <a:p>
-            <a:pPr indent="0" marL="0">
+            <a:pPr marL="0" indent="0">
               <a:buNone/>
             </a:pPr>
             <a:r>
@@ -3360,6 +3152,13 @@
             <a:prstDash val="solid"/>
           </a:ln>
         </p:spPr>
+        <p:txBody>
+          <a:bodyPr/>
+          <a:lstStyle/>
+          <a:p>
+            <a:endParaRPr lang="en-US"/>
+          </a:p>
+        </p:txBody>
       </p:sp>
       <p:sp>
         <p:nvSpPr>
@@ -3382,7 +3181,7 @@
           <a:bodyPr wrap="square" rtlCol="0" anchor="ctr"/>
           <a:lstStyle/>
           <a:p>
-            <a:pPr indent="0" marL="0">
+            <a:pPr marL="0" indent="0">
               <a:buNone/>
             </a:pPr>
             <a:r>
@@ -3421,6 +3220,13 @@
             <a:prstDash val="solid"/>
           </a:ln>
         </p:spPr>
+        <p:txBody>
+          <a:bodyPr/>
+          <a:lstStyle/>
+          <a:p>
+            <a:endParaRPr lang="en-US"/>
+          </a:p>
+        </p:txBody>
       </p:sp>
       <p:sp>
         <p:nvSpPr>
@@ -3443,7 +3249,7 @@
           <a:bodyPr wrap="square" rtlCol="0" anchor="t"/>
           <a:lstStyle/>
           <a:p>
-            <a:pPr indent="0" marL="0">
+            <a:pPr marL="0" indent="0">
               <a:buNone/>
             </a:pPr>
             <a:r>
@@ -3460,7 +3266,7 @@
             <a:endParaRPr lang="en-US" sz="1600" dirty="0"/>
           </a:p>
           <a:p>
-            <a:pPr indent="0" marL="0">
+            <a:pPr marL="0" indent="0">
               <a:buNone/>
             </a:pPr>
             <a:r>
@@ -3499,7 +3305,7 @@
           <a:bodyPr wrap="square" rtlCol="0" anchor="ctr"/>
           <a:lstStyle/>
           <a:p>
-            <a:pPr indent="0" marL="0">
+            <a:pPr marL="0" indent="0">
               <a:buNone/>
             </a:pPr>
             <a:r>
@@ -3509,23 +3315,9 @@
                 </a:solidFill>
               </a:rPr>
               <a:t>Now the question is:
+what does fmap look like when
 </a:t>
             </a:r>
-            <a:pPr indent="0" marL="0">
-              <a:buNone/>
-            </a:pPr>
-            <a:r>
-              <a:rPr lang="en-US" sz="1600" dirty="0">
-                <a:solidFill>
-                  <a:srgbClr val="1A1A2E"/>
-                </a:solidFill>
-              </a:rPr>
-              <a:t>what does fmap look like when
-</a:t>
-            </a:r>
-            <a:pPr indent="0" marL="0">
-              <a:buNone/>
-            </a:pPr>
             <a:r>
               <a:rPr lang="en-US" sz="1600" b="1" dirty="0">
                 <a:solidFill>
@@ -3534,9 +3326,6 @@
               </a:rPr>
               <a:t>f = IO</a:t>
             </a:r>
-            <a:pPr indent="0" marL="0">
-              <a:buNone/>
-            </a:pPr>
             <a:r>
               <a:rPr lang="en-US" sz="1600" dirty="0">
                 <a:solidFill>
@@ -3570,7 +3359,7 @@
           <a:bodyPr wrap="square" rtlCol="0" anchor="ctr"/>
           <a:lstStyle/>
           <a:p>
-            <a:pPr indent="0" marL="0">
+            <a:pPr marL="0" indent="0">
               <a:buNone/>
             </a:pPr>
             <a:r>
@@ -3601,6 +3390,7 @@
         <a:solidFill>
           <a:srgbClr val="F8F9FA"/>
         </a:solidFill>
+        <a:effectLst/>
       </p:bgPr>
     </p:bg>
     <p:spTree>
@@ -3641,6 +3431,13 @@
             <a:prstDash val="solid"/>
           </a:ln>
         </p:spPr>
+        <p:txBody>
+          <a:bodyPr/>
+          <a:lstStyle/>
+          <a:p>
+            <a:endParaRPr lang="en-US"/>
+          </a:p>
+        </p:txBody>
       </p:sp>
       <p:sp>
         <p:nvSpPr>
@@ -3663,7 +3460,7 @@
           <a:bodyPr wrap="square" lIns="0" tIns="0" rIns="0" bIns="0" rtlCol="0" anchor="ctr"/>
           <a:lstStyle/>
           <a:p>
-            <a:pPr indent="0" marL="0">
+            <a:pPr marL="0" indent="0">
               <a:buNone/>
             </a:pPr>
             <a:r>
@@ -3699,7 +3496,7 @@
           <a:bodyPr wrap="square" rtlCol="0" anchor="ctr"/>
           <a:lstStyle/>
           <a:p>
-            <a:pPr indent="0" marL="0">
+            <a:pPr marL="0" indent="0">
               <a:buNone/>
             </a:pPr>
             <a:r>
@@ -3738,6 +3535,13 @@
             <a:prstDash val="solid"/>
           </a:ln>
         </p:spPr>
+        <p:txBody>
+          <a:bodyPr/>
+          <a:lstStyle/>
+          <a:p>
+            <a:endParaRPr lang="en-US"/>
+          </a:p>
+        </p:txBody>
       </p:sp>
       <p:sp>
         <p:nvSpPr>
@@ -3760,7 +3564,7 @@
           <a:bodyPr wrap="square" rtlCol="0" anchor="t"/>
           <a:lstStyle/>
           <a:p>
-            <a:pPr indent="0" marL="0">
+            <a:pPr marL="0" indent="0">
               <a:buNone/>
             </a:pPr>
             <a:r>
@@ -3800,6 +3604,13 @@
             <a:prstDash val="solid"/>
           </a:ln>
         </p:spPr>
+        <p:txBody>
+          <a:bodyPr/>
+          <a:lstStyle/>
+          <a:p>
+            <a:endParaRPr lang="en-US"/>
+          </a:p>
+        </p:txBody>
       </p:sp>
       <p:sp>
         <p:nvSpPr>
@@ -3822,7 +3633,7 @@
           <a:bodyPr wrap="square" rtlCol="0" anchor="ctr"/>
           <a:lstStyle/>
           <a:p>
-            <a:pPr algn="ctr" indent="0" marL="0">
+            <a:pPr marL="0" indent="0" algn="ctr">
               <a:buNone/>
             </a:pPr>
             <a:r>
@@ -3859,6 +3670,13 @@
             <a:prstDash val="solid"/>
           </a:ln>
         </p:spPr>
+        <p:txBody>
+          <a:bodyPr/>
+          <a:lstStyle/>
+          <a:p>
+            <a:endParaRPr lang="en-US"/>
+          </a:p>
+        </p:txBody>
       </p:sp>
       <p:sp>
         <p:nvSpPr>
@@ -3881,7 +3699,7 @@
           <a:bodyPr wrap="square" rtlCol="0" anchor="ctr"/>
           <a:lstStyle/>
           <a:p>
-            <a:pPr algn="ctr" indent="0" marL="0">
+            <a:pPr marL="0" indent="0" algn="ctr">
               <a:buNone/>
             </a:pPr>
             <a:r>
@@ -3895,7 +3713,7 @@
             <a:endParaRPr lang="en-US" sz="1300" dirty="0"/>
           </a:p>
           <a:p>
-            <a:pPr algn="ctr" indent="0" marL="0">
+            <a:pPr marL="0" indent="0" algn="ctr">
               <a:buNone/>
             </a:pPr>
             <a:r>
@@ -3932,6 +3750,13 @@
             <a:prstDash val="solid"/>
           </a:ln>
         </p:spPr>
+        <p:txBody>
+          <a:bodyPr/>
+          <a:lstStyle/>
+          <a:p>
+            <a:endParaRPr lang="en-US"/>
+          </a:p>
+        </p:txBody>
       </p:sp>
       <p:sp>
         <p:nvSpPr>
@@ -3954,7 +3779,7 @@
           <a:bodyPr wrap="square" rtlCol="0" anchor="ctr"/>
           <a:lstStyle/>
           <a:p>
-            <a:pPr algn="ctr" indent="0" marL="0">
+            <a:pPr marL="0" indent="0" algn="ctr">
               <a:buNone/>
             </a:pPr>
             <a:r>
@@ -3968,7 +3793,7 @@
             <a:endParaRPr lang="en-US" sz="1300" dirty="0"/>
           </a:p>
           <a:p>
-            <a:pPr algn="ctr" indent="0" marL="0">
+            <a:pPr marL="0" indent="0" algn="ctr">
               <a:buNone/>
             </a:pPr>
             <a:r>
@@ -4004,7 +3829,7 @@
           <a:bodyPr wrap="square" rtlCol="0" anchor="ctr"/>
           <a:lstStyle/>
           <a:p>
-            <a:pPr indent="0" marL="0">
+            <a:pPr marL="0" indent="0">
               <a:buNone/>
             </a:pPr>
             <a:r>
@@ -4040,7 +3865,7 @@
           <a:bodyPr wrap="square" rtlCol="0" anchor="ctr"/>
           <a:lstStyle/>
           <a:p>
-            <a:pPr indent="0" marL="0">
+            <a:pPr marL="0" indent="0">
               <a:buNone/>
             </a:pPr>
             <a:r>
@@ -4051,9 +3876,6 @@
               </a:rPr>
               <a:t>Given a function  </a:t>
             </a:r>
-            <a:pPr indent="0" marL="0">
-              <a:buNone/>
-            </a:pPr>
             <a:r>
               <a:rPr lang="en-US" sz="1800" b="1" dirty="0">
                 <a:solidFill>
@@ -4065,9 +3887,6 @@
               </a:rPr>
               <a:t>f :: a -&gt; b</a:t>
             </a:r>
-            <a:pPr indent="0" marL="0">
-              <a:buNone/>
-            </a:pPr>
             <a:r>
               <a:rPr lang="en-US" sz="1800" dirty="0">
                 <a:solidFill>
@@ -4076,9 +3895,6 @@
               </a:rPr>
               <a:t>  and an IO interaction  </a:t>
             </a:r>
-            <a:pPr indent="0" marL="0">
-              <a:buNone/>
-            </a:pPr>
             <a:r>
               <a:rPr lang="en-US" sz="1800" b="1" dirty="0">
                 <a:solidFill>
@@ -4090,9 +3906,6 @@
               </a:rPr>
               <a:t>m :: IO a</a:t>
             </a:r>
-            <a:pPr indent="0" marL="0">
-              <a:buNone/>
-            </a:pPr>
             <a:r>
               <a:rPr lang="en-US" sz="1800" dirty="0">
                 <a:solidFill>
@@ -4104,7 +3917,7 @@
             <a:endParaRPr lang="en-US" sz="1800" dirty="0"/>
           </a:p>
           <a:p>
-            <a:pPr indent="0" marL="0">
+            <a:pPr marL="0" indent="0">
               <a:buNone/>
             </a:pPr>
             <a:r>
@@ -4118,7 +3931,7 @@
             <a:endParaRPr lang="en-US" sz="1800" dirty="0"/>
           </a:p>
           <a:p>
-            <a:pPr indent="0" marL="0">
+            <a:pPr marL="0" indent="0">
               <a:buNone/>
             </a:pPr>
             <a:r>
@@ -4132,9 +3945,6 @@
               </a:rPr>
               <a:t>f</a:t>
             </a:r>
-            <a:pPr indent="0" marL="0">
-              <a:buNone/>
-            </a:pPr>
             <a:r>
               <a:rPr lang="en-US" sz="1800" dirty="0">
                 <a:solidFill>
@@ -4163,6 +3973,7 @@
         <a:solidFill>
           <a:srgbClr val="F8F9FA"/>
         </a:solidFill>
+        <a:effectLst/>
       </p:bgPr>
     </p:bg>
     <p:spTree>
@@ -4203,6 +4014,13 @@
             <a:prstDash val="solid"/>
           </a:ln>
         </p:spPr>
+        <p:txBody>
+          <a:bodyPr/>
+          <a:lstStyle/>
+          <a:p>
+            <a:endParaRPr lang="en-US"/>
+          </a:p>
+        </p:txBody>
       </p:sp>
       <p:sp>
         <p:nvSpPr>
@@ -4225,7 +4043,7 @@
           <a:bodyPr wrap="square" lIns="0" tIns="0" rIns="0" bIns="0" rtlCol="0" anchor="ctr"/>
           <a:lstStyle/>
           <a:p>
-            <a:pPr indent="0" marL="0">
+            <a:pPr marL="0" indent="0">
               <a:buNone/>
             </a:pPr>
             <a:r>
@@ -4261,7 +4079,7 @@
           <a:bodyPr wrap="square" rtlCol="0" anchor="ctr"/>
           <a:lstStyle/>
           <a:p>
-            <a:pPr indent="0" marL="0">
+            <a:pPr marL="0" indent="0">
               <a:buNone/>
             </a:pPr>
             <a:r>
@@ -4300,6 +4118,13 @@
             <a:prstDash val="solid"/>
           </a:ln>
         </p:spPr>
+        <p:txBody>
+          <a:bodyPr/>
+          <a:lstStyle/>
+          <a:p>
+            <a:endParaRPr lang="en-US"/>
+          </a:p>
+        </p:txBody>
       </p:sp>
       <p:sp>
         <p:nvSpPr>
@@ -4322,7 +4147,7 @@
           <a:bodyPr wrap="square" lIns="0" tIns="0" rIns="0" bIns="0" rtlCol="0" anchor="ctr"/>
           <a:lstStyle/>
           <a:p>
-            <a:pPr algn="ctr" indent="0" marL="0">
+            <a:pPr marL="0" indent="0" algn="ctr">
               <a:buNone/>
             </a:pPr>
             <a:r>
@@ -4358,7 +4183,7 @@
           <a:bodyPr wrap="square" rtlCol="0" anchor="ctr"/>
           <a:lstStyle/>
           <a:p>
-            <a:pPr indent="0" marL="0">
+            <a:pPr marL="0" indent="0">
               <a:buNone/>
             </a:pPr>
             <a:r>
@@ -4397,6 +4222,13 @@
             <a:prstDash val="solid"/>
           </a:ln>
         </p:spPr>
+        <p:txBody>
+          <a:bodyPr/>
+          <a:lstStyle/>
+          <a:p>
+            <a:endParaRPr lang="en-US"/>
+          </a:p>
+        </p:txBody>
       </p:sp>
       <p:sp>
         <p:nvSpPr>
@@ -4419,7 +4251,7 @@
           <a:bodyPr wrap="square" rtlCol="0" anchor="t"/>
           <a:lstStyle/>
           <a:p>
-            <a:pPr indent="0" marL="0">
+            <a:pPr marL="0" indent="0">
               <a:buNone/>
             </a:pPr>
             <a:r>
@@ -4461,6 +4293,13 @@
             <a:prstDash val="solid"/>
           </a:ln>
         </p:spPr>
+        <p:txBody>
+          <a:bodyPr/>
+          <a:lstStyle/>
+          <a:p>
+            <a:endParaRPr lang="en-US"/>
+          </a:p>
+        </p:txBody>
       </p:sp>
       <p:sp>
         <p:nvSpPr>
@@ -4483,7 +4322,7 @@
           <a:bodyPr wrap="square" lIns="0" tIns="0" rIns="0" bIns="0" rtlCol="0" anchor="ctr"/>
           <a:lstStyle/>
           <a:p>
-            <a:pPr algn="ctr" indent="0" marL="0">
+            <a:pPr marL="0" indent="0" algn="ctr">
               <a:buNone/>
             </a:pPr>
             <a:r>
@@ -4519,7 +4358,7 @@
           <a:bodyPr wrap="square" rtlCol="0" anchor="ctr"/>
           <a:lstStyle/>
           <a:p>
-            <a:pPr indent="0" marL="0">
+            <a:pPr marL="0" indent="0">
               <a:buNone/>
             </a:pPr>
             <a:r>
@@ -4558,6 +4397,13 @@
             <a:prstDash val="solid"/>
           </a:ln>
         </p:spPr>
+        <p:txBody>
+          <a:bodyPr/>
+          <a:lstStyle/>
+          <a:p>
+            <a:endParaRPr lang="en-US"/>
+          </a:p>
+        </p:txBody>
       </p:sp>
       <p:sp>
         <p:nvSpPr>
@@ -4580,7 +4426,7 @@
           <a:bodyPr wrap="square" rtlCol="0" anchor="t"/>
           <a:lstStyle/>
           <a:p>
-            <a:pPr indent="0" marL="0">
+            <a:pPr marL="0" indent="0">
               <a:buNone/>
             </a:pPr>
             <a:r>
@@ -4622,6 +4468,13 @@
             <a:prstDash val="solid"/>
           </a:ln>
         </p:spPr>
+        <p:txBody>
+          <a:bodyPr/>
+          <a:lstStyle/>
+          <a:p>
+            <a:endParaRPr lang="en-US"/>
+          </a:p>
+        </p:txBody>
       </p:sp>
       <p:sp>
         <p:nvSpPr>
@@ -4644,7 +4497,7 @@
           <a:bodyPr wrap="square" lIns="0" tIns="0" rIns="0" bIns="0" rtlCol="0" anchor="ctr"/>
           <a:lstStyle/>
           <a:p>
-            <a:pPr algn="ctr" indent="0" marL="0">
+            <a:pPr marL="0" indent="0" algn="ctr">
               <a:buNone/>
             </a:pPr>
             <a:r>
@@ -4680,7 +4533,7 @@
           <a:bodyPr wrap="square" rtlCol="0" anchor="ctr"/>
           <a:lstStyle/>
           <a:p>
-            <a:pPr indent="0" marL="0">
+            <a:pPr marL="0" indent="0">
               <a:buNone/>
             </a:pPr>
             <a:r>
@@ -4719,6 +4572,13 @@
             <a:prstDash val="solid"/>
           </a:ln>
         </p:spPr>
+        <p:txBody>
+          <a:bodyPr/>
+          <a:lstStyle/>
+          <a:p>
+            <a:endParaRPr lang="en-US"/>
+          </a:p>
+        </p:txBody>
       </p:sp>
       <p:sp>
         <p:nvSpPr>
@@ -4741,7 +4601,7 @@
           <a:bodyPr wrap="square" rtlCol="0" anchor="t"/>
           <a:lstStyle/>
           <a:p>
-            <a:pPr indent="0" marL="0">
+            <a:pPr marL="0" indent="0">
               <a:buNone/>
             </a:pPr>
             <a:r>
@@ -4783,6 +4643,13 @@
             <a:prstDash val="solid"/>
           </a:ln>
         </p:spPr>
+        <p:txBody>
+          <a:bodyPr/>
+          <a:lstStyle/>
+          <a:p>
+            <a:endParaRPr lang="en-US"/>
+          </a:p>
+        </p:txBody>
       </p:sp>
       <p:sp>
         <p:nvSpPr>
@@ -4805,7 +4672,7 @@
           <a:bodyPr wrap="square" rtlCol="0" anchor="ctr"/>
           <a:lstStyle/>
           <a:p>
-            <a:pPr indent="0" marL="0">
+            <a:pPr marL="0" indent="0">
               <a:buNone/>
             </a:pPr>
             <a:r>
@@ -4844,6 +4711,13 @@
             <a:prstDash val="solid"/>
           </a:ln>
         </p:spPr>
+        <p:txBody>
+          <a:bodyPr/>
+          <a:lstStyle/>
+          <a:p>
+            <a:endParaRPr lang="en-US"/>
+          </a:p>
+        </p:txBody>
       </p:sp>
       <p:sp>
         <p:nvSpPr>
@@ -4866,7 +4740,7 @@
           <a:bodyPr wrap="square" rtlCol="0" anchor="t"/>
           <a:lstStyle/>
           <a:p>
-            <a:pPr indent="0" marL="0">
+            <a:pPr marL="0" indent="0">
               <a:buNone/>
             </a:pPr>
             <a:r>
@@ -4883,7 +4757,7 @@
             <a:endParaRPr lang="en-US" sz="1800" dirty="0"/>
           </a:p>
           <a:p>
-            <a:pPr indent="0" marL="0">
+            <a:pPr marL="0" indent="0">
               <a:buNone/>
             </a:pPr>
             <a:r>
@@ -4900,7 +4774,7 @@
             <a:endParaRPr lang="en-US" sz="1800" dirty="0"/>
           </a:p>
           <a:p>
-            <a:pPr indent="0" marL="0">
+            <a:pPr marL="0" indent="0">
               <a:buNone/>
             </a:pPr>
             <a:r>
@@ -4939,7 +4813,7 @@
           <a:bodyPr wrap="square" rtlCol="0" anchor="ctr"/>
           <a:lstStyle/>
           <a:p>
-            <a:pPr indent="0" marL="0">
+            <a:pPr marL="0" indent="0">
               <a:buNone/>
             </a:pPr>
             <a:r>
@@ -4953,7 +4827,7 @@
             <a:endParaRPr lang="en-US" sz="1400" dirty="0"/>
           </a:p>
           <a:p>
-            <a:pPr indent="0" marL="0">
+            <a:pPr marL="0" indent="0">
               <a:buNone/>
             </a:pPr>
             <a:r>
@@ -4984,6 +4858,7 @@
         <a:solidFill>
           <a:srgbClr val="F8F9FA"/>
         </a:solidFill>
+        <a:effectLst/>
       </p:bgPr>
     </p:bg>
     <p:spTree>
@@ -5024,6 +4899,13 @@
             <a:prstDash val="solid"/>
           </a:ln>
         </p:spPr>
+        <p:txBody>
+          <a:bodyPr/>
+          <a:lstStyle/>
+          <a:p>
+            <a:endParaRPr lang="en-US"/>
+          </a:p>
+        </p:txBody>
       </p:sp>
       <p:sp>
         <p:nvSpPr>
@@ -5046,7 +4928,7 @@
           <a:bodyPr wrap="square" lIns="0" tIns="0" rIns="0" bIns="0" rtlCol="0" anchor="ctr"/>
           <a:lstStyle/>
           <a:p>
-            <a:pPr indent="0" marL="0">
+            <a:pPr marL="0" indent="0">
               <a:buNone/>
             </a:pPr>
             <a:r>
@@ -5085,6 +4967,13 @@
             <a:prstDash val="solid"/>
           </a:ln>
         </p:spPr>
+        <p:txBody>
+          <a:bodyPr/>
+          <a:lstStyle/>
+          <a:p>
+            <a:endParaRPr lang="en-US"/>
+          </a:p>
+        </p:txBody>
       </p:sp>
       <p:sp>
         <p:nvSpPr>
@@ -5107,7 +4996,7 @@
           <a:bodyPr wrap="square" rtlCol="0" anchor="t"/>
           <a:lstStyle/>
           <a:p>
-            <a:pPr indent="0" marL="0">
+            <a:pPr marL="0" indent="0">
               <a:buNone/>
             </a:pPr>
             <a:r>
@@ -5124,7 +5013,7 @@
             <a:endParaRPr lang="en-US" sz="2200" dirty="0"/>
           </a:p>
           <a:p>
-            <a:pPr indent="0" marL="0">
+            <a:pPr marL="0" indent="0">
               <a:buNone/>
             </a:pPr>
             <a:r>
@@ -5141,7 +5030,7 @@
             <a:endParaRPr lang="en-US" sz="2200" dirty="0"/>
           </a:p>
           <a:p>
-            <a:pPr indent="0" marL="0">
+            <a:pPr marL="0" indent="0">
               <a:buNone/>
             </a:pPr>
             <a:r>
@@ -5158,7 +5047,7 @@
             <a:endParaRPr lang="en-US" sz="2200" dirty="0"/>
           </a:p>
           <a:p>
-            <a:pPr indent="0" marL="0">
+            <a:pPr marL="0" indent="0">
               <a:buNone/>
             </a:pPr>
             <a:r>
@@ -5197,7 +5086,7 @@
           <a:bodyPr wrap="square" rtlCol="0" anchor="ctr"/>
           <a:lstStyle/>
           <a:p>
-            <a:pPr indent="0" marL="0">
+            <a:pPr marL="0" indent="0">
               <a:buNone/>
             </a:pPr>
             <a:r>
@@ -5233,7 +5122,7 @@
           <a:bodyPr wrap="square" rtlCol="0" anchor="ctr"/>
           <a:lstStyle/>
           <a:p>
-            <a:pPr indent="0" marL="0">
+            <a:pPr marL="0" indent="0">
               <a:buNone/>
             </a:pPr>
             <a:r>
@@ -5272,6 +5161,13 @@
             <a:prstDash val="solid"/>
           </a:ln>
         </p:spPr>
+        <p:txBody>
+          <a:bodyPr/>
+          <a:lstStyle/>
+          <a:p>
+            <a:endParaRPr lang="en-US"/>
+          </a:p>
+        </p:txBody>
       </p:sp>
       <p:sp>
         <p:nvSpPr>
@@ -5294,7 +5190,7 @@
           <a:bodyPr wrap="square" rtlCol="0" anchor="t"/>
           <a:lstStyle/>
           <a:p>
-            <a:pPr indent="0" marL="0">
+            <a:pPr marL="0" indent="0">
               <a:buNone/>
             </a:pPr>
             <a:r>
@@ -5311,13 +5207,13 @@
             <a:endParaRPr lang="en-US" sz="1600" dirty="0"/>
           </a:p>
           <a:p>
-            <a:pPr indent="0" marL="0">
+            <a:pPr marL="0" indent="0">
               <a:buNone/>
             </a:pPr>
             <a:endParaRPr lang="en-US" sz="1600" dirty="0"/>
           </a:p>
           <a:p>
-            <a:pPr indent="0" marL="0">
+            <a:pPr marL="0" indent="0">
               <a:buNone/>
             </a:pPr>
             <a:r>
@@ -5334,7 +5230,7 @@
             <a:endParaRPr lang="en-US" sz="1600" dirty="0"/>
           </a:p>
           <a:p>
-            <a:pPr indent="0" marL="0">
+            <a:pPr marL="0" indent="0">
               <a:buNone/>
             </a:pPr>
             <a:r>
@@ -5351,7 +5247,7 @@
             <a:endParaRPr lang="en-US" sz="1600" dirty="0"/>
           </a:p>
           <a:p>
-            <a:pPr indent="0" marL="0">
+            <a:pPr marL="0" indent="0">
               <a:buNone/>
             </a:pPr>
             <a:r>
@@ -5368,13 +5264,13 @@
             <a:endParaRPr lang="en-US" sz="1600" dirty="0"/>
           </a:p>
           <a:p>
-            <a:pPr indent="0" marL="0">
+            <a:pPr marL="0" indent="0">
               <a:buNone/>
             </a:pPr>
             <a:endParaRPr lang="en-US" sz="1600" dirty="0"/>
           </a:p>
           <a:p>
-            <a:pPr indent="0" marL="0">
+            <a:pPr marL="0" indent="0">
               <a:buNone/>
             </a:pPr>
             <a:r>
@@ -5391,7 +5287,7 @@
             <a:endParaRPr lang="en-US" sz="1600" dirty="0"/>
           </a:p>
           <a:p>
-            <a:pPr indent="0" marL="0">
+            <a:pPr marL="0" indent="0">
               <a:buNone/>
             </a:pPr>
             <a:r>
@@ -5433,6 +5329,13 @@
             <a:prstDash val="solid"/>
           </a:ln>
         </p:spPr>
+        <p:txBody>
+          <a:bodyPr/>
+          <a:lstStyle/>
+          <a:p>
+            <a:endParaRPr lang="en-US"/>
+          </a:p>
+        </p:txBody>
       </p:sp>
       <p:sp>
         <p:nvSpPr>
@@ -5455,7 +5358,7 @@
           <a:bodyPr wrap="square" rtlCol="0" anchor="ctr"/>
           <a:lstStyle/>
           <a:p>
-            <a:pPr indent="0" marL="0">
+            <a:pPr marL="0" indent="0">
               <a:buNone/>
             </a:pPr>
             <a:r>
@@ -5491,7 +5394,7 @@
           <a:bodyPr wrap="square" rtlCol="0" anchor="ctr"/>
           <a:lstStyle/>
           <a:p>
-            <a:pPr indent="0" marL="0">
+            <a:pPr marL="0" indent="0">
               <a:buNone/>
             </a:pPr>
             <a:r>
@@ -5505,13 +5408,13 @@
             <a:endParaRPr lang="en-US" sz="1400" dirty="0"/>
           </a:p>
           <a:p>
-            <a:pPr indent="0" marL="0">
+            <a:pPr marL="0" indent="0">
               <a:buNone/>
             </a:pPr>
             <a:endParaRPr lang="en-US" sz="1400" dirty="0"/>
           </a:p>
           <a:p>
-            <a:pPr indent="0" marL="0">
+            <a:pPr marL="0" indent="0">
               <a:buNone/>
             </a:pPr>
             <a:r>
@@ -5542,6 +5445,7 @@
         <a:solidFill>
           <a:srgbClr val="1A4E3A"/>
         </a:solidFill>
+        <a:effectLst/>
       </p:bgPr>
     </p:bg>
     <p:spTree>
@@ -5579,7 +5483,7 @@
           <a:bodyPr wrap="square" rtlCol="0" anchor="ctr"/>
           <a:lstStyle/>
           <a:p>
-            <a:pPr algn="ctr" indent="0" marL="0">
+            <a:pPr marL="0" indent="0" algn="ctr">
               <a:buNone/>
             </a:pPr>
             <a:r>
@@ -5615,7 +5519,7 @@
           <a:bodyPr wrap="square" rtlCol="0" anchor="ctr"/>
           <a:lstStyle/>
           <a:p>
-            <a:pPr algn="ctr" indent="0" marL="0">
+            <a:pPr marL="0" indent="0" algn="ctr">
               <a:buNone/>
             </a:pPr>
             <a:r>
@@ -5646,6 +5550,7 @@
         <a:solidFill>
           <a:srgbClr val="F8F9FA"/>
         </a:solidFill>
+        <a:effectLst/>
       </p:bgPr>
     </p:bg>
     <p:spTree>
@@ -5686,6 +5591,13 @@
             <a:prstDash val="solid"/>
           </a:ln>
         </p:spPr>
+        <p:txBody>
+          <a:bodyPr/>
+          <a:lstStyle/>
+          <a:p>
+            <a:endParaRPr lang="en-US"/>
+          </a:p>
+        </p:txBody>
       </p:sp>
       <p:sp>
         <p:nvSpPr>
@@ -5708,7 +5620,7 @@
           <a:bodyPr wrap="square" lIns="0" tIns="0" rIns="0" bIns="0" rtlCol="0" anchor="ctr"/>
           <a:lstStyle/>
           <a:p>
-            <a:pPr indent="0" marL="0">
+            <a:pPr marL="0" indent="0">
               <a:buNone/>
             </a:pPr>
             <a:r>
@@ -5744,7 +5656,7 @@
           <a:bodyPr wrap="square" rtlCol="0" anchor="ctr"/>
           <a:lstStyle/>
           <a:p>
-            <a:pPr indent="0" marL="0">
+            <a:pPr marL="0" indent="0">
               <a:buNone/>
             </a:pPr>
             <a:r>
@@ -5783,6 +5695,13 @@
             <a:prstDash val="solid"/>
           </a:ln>
         </p:spPr>
+        <p:txBody>
+          <a:bodyPr/>
+          <a:lstStyle/>
+          <a:p>
+            <a:endParaRPr lang="en-US"/>
+          </a:p>
+        </p:txBody>
       </p:sp>
       <p:sp>
         <p:nvSpPr>
@@ -5805,7 +5724,7 @@
           <a:bodyPr wrap="square" rtlCol="0" anchor="t"/>
           <a:lstStyle/>
           <a:p>
-            <a:pPr indent="0" marL="0">
+            <a:pPr marL="0" indent="0">
               <a:buNone/>
             </a:pPr>
             <a:r>
@@ -5844,7 +5763,7 @@
           <a:bodyPr wrap="square" rtlCol="0" anchor="ctr"/>
           <a:lstStyle/>
           <a:p>
-            <a:pPr indent="0" marL="0">
+            <a:pPr marL="0" indent="0">
               <a:buNone/>
             </a:pPr>
             <a:r>
@@ -5883,6 +5802,13 @@
             <a:prstDash val="solid"/>
           </a:ln>
         </p:spPr>
+        <p:txBody>
+          <a:bodyPr/>
+          <a:lstStyle/>
+          <a:p>
+            <a:endParaRPr lang="en-US"/>
+          </a:p>
+        </p:txBody>
       </p:sp>
       <p:sp>
         <p:nvSpPr>
@@ -5905,7 +5831,7 @@
           <a:bodyPr wrap="square" rtlCol="0" anchor="t"/>
           <a:lstStyle/>
           <a:p>
-            <a:pPr indent="0" marL="0">
+            <a:pPr marL="0" indent="0">
               <a:buNone/>
             </a:pPr>
             <a:r>
@@ -5944,7 +5870,7 @@
           <a:bodyPr wrap="square" rtlCol="0" anchor="ctr"/>
           <a:lstStyle/>
           <a:p>
-            <a:pPr indent="0" marL="0">
+            <a:pPr marL="0" indent="0">
               <a:buNone/>
             </a:pPr>
             <a:r>
@@ -5983,6 +5909,13 @@
             <a:prstDash val="solid"/>
           </a:ln>
         </p:spPr>
+        <p:txBody>
+          <a:bodyPr/>
+          <a:lstStyle/>
+          <a:p>
+            <a:endParaRPr lang="en-US"/>
+          </a:p>
+        </p:txBody>
       </p:sp>
       <p:sp>
         <p:nvSpPr>
@@ -6005,7 +5938,7 @@
           <a:bodyPr wrap="square" rtlCol="0" anchor="ctr"/>
           <a:lstStyle/>
           <a:p>
-            <a:pPr indent="0" marL="0">
+            <a:pPr marL="0" indent="0">
               <a:buNone/>
             </a:pPr>
             <a:r>
@@ -6041,7 +5974,7 @@
           <a:bodyPr wrap="square" rtlCol="0" anchor="ctr"/>
           <a:lstStyle/>
           <a:p>
-            <a:pPr indent="0" marL="0">
+            <a:pPr marL="0" indent="0">
               <a:buNone/>
             </a:pPr>
             <a:r>
@@ -6055,9 +5988,6 @@
               </a:rPr>
               <a:t>IO Bool</a:t>
             </a:r>
-            <a:pPr indent="0" marL="0">
-              <a:buNone/>
-            </a:pPr>
             <a:r>
               <a:rPr lang="en-US" sz="1300" dirty="0">
                 <a:solidFill>
@@ -6068,9 +5998,6 @@
 → an action that checks a condition
 </a:t>
             </a:r>
-            <a:pPr indent="0" marL="0">
-              <a:buNone/>
-            </a:pPr>
             <a:r>
               <a:rPr lang="en-US" sz="1300" b="1" dirty="0">
                 <a:solidFill>
@@ -6082,9 +6009,6 @@
               </a:rPr>
               <a:t>IO ()</a:t>
             </a:r>
-            <a:pPr indent="0" marL="0">
-              <a:buNone/>
-            </a:pPr>
             <a:r>
               <a:rPr lang="en-US" sz="1300" dirty="0">
                 <a:solidFill>
@@ -6096,9 +6020,6 @@
    (result discarded)
 </a:t>
             </a:r>
-            <a:pPr indent="0" marL="0">
-              <a:buNone/>
-            </a:pPr>
             <a:r>
               <a:rPr lang="en-US" sz="1300" b="1" dirty="0">
                 <a:solidFill>
@@ -6110,13 +6031,10 @@
               </a:rPr>
               <a:t>IO ()</a:t>
             </a:r>
-            <a:pPr indent="0" marL="0">
-              <a:buNone/>
-            </a:pPr>
             <a:endParaRPr lang="en-US" sz="1300" dirty="0"/>
           </a:p>
           <a:p>
-            <a:pPr indent="0" marL="0">
+            <a:pPr marL="0" indent="0">
               <a:buNone/>
             </a:pPr>
             <a:r>
@@ -6152,7 +6070,7 @@
           <a:bodyPr wrap="square" rtlCol="0" anchor="ctr"/>
           <a:lstStyle/>
           <a:p>
-            <a:pPr indent="0" marL="0">
+            <a:pPr marL="0" indent="0">
               <a:buNone/>
             </a:pPr>
             <a:r>
@@ -6183,6 +6101,7 @@
         <a:solidFill>
           <a:srgbClr val="F8F9FA"/>
         </a:solidFill>
+        <a:effectLst/>
       </p:bgPr>
     </p:bg>
     <p:spTree>
@@ -6223,6 +6142,13 @@
             <a:prstDash val="solid"/>
           </a:ln>
         </p:spPr>
+        <p:txBody>
+          <a:bodyPr/>
+          <a:lstStyle/>
+          <a:p>
+            <a:endParaRPr lang="en-US"/>
+          </a:p>
+        </p:txBody>
       </p:sp>
       <p:sp>
         <p:nvSpPr>
@@ -6245,7 +6171,7 @@
           <a:bodyPr wrap="square" lIns="0" tIns="0" rIns="0" bIns="0" rtlCol="0" anchor="ctr"/>
           <a:lstStyle/>
           <a:p>
-            <a:pPr indent="0" marL="0">
+            <a:pPr marL="0" indent="0">
               <a:buNone/>
             </a:pPr>
             <a:r>
@@ -6281,7 +6207,7 @@
           <a:bodyPr wrap="square" rtlCol="0" anchor="ctr"/>
           <a:lstStyle/>
           <a:p>
-            <a:pPr indent="0" marL="0">
+            <a:pPr marL="0" indent="0">
               <a:buNone/>
             </a:pPr>
             <a:r>
@@ -6317,7 +6243,7 @@
           <a:bodyPr wrap="square" rtlCol="0" anchor="ctr"/>
           <a:lstStyle/>
           <a:p>
-            <a:pPr indent="0" marL="0">
+            <a:pPr marL="0" indent="0">
               <a:buNone/>
             </a:pPr>
             <a:r>
@@ -6356,6 +6282,13 @@
             <a:prstDash val="solid"/>
           </a:ln>
         </p:spPr>
+        <p:txBody>
+          <a:bodyPr/>
+          <a:lstStyle/>
+          <a:p>
+            <a:endParaRPr lang="en-US"/>
+          </a:p>
+        </p:txBody>
       </p:sp>
       <p:sp>
         <p:nvSpPr>
@@ -6378,7 +6311,7 @@
           <a:bodyPr wrap="square" rtlCol="0" anchor="t"/>
           <a:lstStyle/>
           <a:p>
-            <a:pPr indent="0" marL="0">
+            <a:pPr marL="0" indent="0">
               <a:buNone/>
             </a:pPr>
             <a:r>
@@ -6395,7 +6328,7 @@
             <a:endParaRPr lang="en-US" sz="1700" dirty="0"/>
           </a:p>
           <a:p>
-            <a:pPr indent="0" marL="0">
+            <a:pPr marL="0" indent="0">
               <a:buNone/>
             </a:pPr>
             <a:r>
@@ -6412,7 +6345,7 @@
             <a:endParaRPr lang="en-US" sz="1700" dirty="0"/>
           </a:p>
           <a:p>
-            <a:pPr indent="0" marL="0">
+            <a:pPr marL="0" indent="0">
               <a:buNone/>
             </a:pPr>
             <a:r>
@@ -6451,7 +6384,7 @@
           <a:bodyPr wrap="square" rtlCol="0" anchor="ctr"/>
           <a:lstStyle/>
           <a:p>
-            <a:pPr indent="0" marL="0">
+            <a:pPr marL="0" indent="0">
               <a:buNone/>
             </a:pPr>
             <a:r>
@@ -6490,6 +6423,13 @@
             <a:prstDash val="solid"/>
           </a:ln>
         </p:spPr>
+        <p:txBody>
+          <a:bodyPr/>
+          <a:lstStyle/>
+          <a:p>
+            <a:endParaRPr lang="en-US"/>
+          </a:p>
+        </p:txBody>
       </p:sp>
       <p:sp>
         <p:nvSpPr>
@@ -6512,7 +6452,7 @@
           <a:bodyPr wrap="square" rtlCol="0" anchor="t"/>
           <a:lstStyle/>
           <a:p>
-            <a:pPr indent="0" marL="0">
+            <a:pPr marL="0" indent="0">
               <a:buNone/>
             </a:pPr>
             <a:r>
@@ -6529,7 +6469,7 @@
             <a:endParaRPr lang="en-US" sz="1700" dirty="0"/>
           </a:p>
           <a:p>
-            <a:pPr indent="0" marL="0">
+            <a:pPr marL="0" indent="0">
               <a:buNone/>
             </a:pPr>
             <a:r>
@@ -6571,6 +6511,13 @@
             <a:prstDash val="solid"/>
           </a:ln>
         </p:spPr>
+        <p:txBody>
+          <a:bodyPr/>
+          <a:lstStyle/>
+          <a:p>
+            <a:endParaRPr lang="en-US"/>
+          </a:p>
+        </p:txBody>
       </p:sp>
       <p:sp>
         <p:nvSpPr>
@@ -6593,7 +6540,7 @@
           <a:bodyPr wrap="square" rtlCol="0" anchor="ctr"/>
           <a:lstStyle/>
           <a:p>
-            <a:pPr indent="0" marL="0">
+            <a:pPr marL="0" indent="0">
               <a:buNone/>
             </a:pPr>
             <a:r>
@@ -6629,7 +6576,7 @@
           <a:bodyPr wrap="square" rtlCol="0" anchor="ctr"/>
           <a:lstStyle/>
           <a:p>
-            <a:pPr indent="0" marL="0">
+            <a:pPr marL="0" indent="0">
               <a:buNone/>
             </a:pPr>
             <a:r>
@@ -6646,7 +6593,7 @@
             <a:endParaRPr lang="en-US" sz="1400" dirty="0"/>
           </a:p>
           <a:p>
-            <a:pPr indent="0" marL="0">
+            <a:pPr marL="0" indent="0">
               <a:buNone/>
             </a:pPr>
             <a:r>
@@ -6663,7 +6610,7 @@
             <a:endParaRPr lang="en-US" sz="1400" dirty="0"/>
           </a:p>
           <a:p>
-            <a:pPr indent="0" marL="0">
+            <a:pPr marL="0" indent="0">
               <a:buNone/>
             </a:pPr>
             <a:r>
@@ -6680,7 +6627,7 @@
             <a:endParaRPr lang="en-US" sz="1400" dirty="0"/>
           </a:p>
           <a:p>
-            <a:pPr indent="0" marL="0">
+            <a:pPr marL="0" indent="0">
               <a:buNone/>
             </a:pPr>
             <a:r>
@@ -6697,7 +6644,7 @@
             <a:endParaRPr lang="en-US" sz="1400" dirty="0"/>
           </a:p>
           <a:p>
-            <a:pPr indent="0" marL="0">
+            <a:pPr marL="0" indent="0">
               <a:buNone/>
             </a:pPr>
             <a:r>
@@ -6714,7 +6661,7 @@
             <a:endParaRPr lang="en-US" sz="1400" dirty="0"/>
           </a:p>
           <a:p>
-            <a:pPr indent="0" marL="0">
+            <a:pPr marL="0" indent="0">
               <a:buNone/>
             </a:pPr>
             <a:r>
@@ -6731,7 +6678,7 @@
             <a:endParaRPr lang="en-US" sz="1400" dirty="0"/>
           </a:p>
           <a:p>
-            <a:pPr indent="0" marL="0">
+            <a:pPr marL="0" indent="0">
               <a:buNone/>
             </a:pPr>
             <a:r>
@@ -6748,7 +6695,7 @@
             <a:endParaRPr lang="en-US" sz="1400" dirty="0"/>
           </a:p>
           <a:p>
-            <a:pPr indent="0" marL="0">
+            <a:pPr marL="0" indent="0">
               <a:buNone/>
             </a:pPr>
             <a:r>
@@ -6787,7 +6734,7 @@
           <a:bodyPr wrap="square" rtlCol="0" anchor="ctr"/>
           <a:lstStyle/>
           <a:p>
-            <a:pPr indent="0" marL="0">
+            <a:pPr marL="0" indent="0">
               <a:buNone/>
             </a:pPr>
             <a:r>
@@ -7103,4 +7050,319 @@
     </a:ext>
   </a:extLst>
 </a:theme>
+</file>
+
+<file path=ppt/theme/theme2.xml><?xml version="1.0" encoding="utf-8"?>
+<a:theme xmlns:a="http://schemas.openxmlformats.org/drawingml/2006/main" name="Office Theme">
+  <a:themeElements>
+    <a:clrScheme name="Office">
+      <a:dk1>
+        <a:sysClr val="windowText" lastClr="000000"/>
+      </a:dk1>
+      <a:lt1>
+        <a:sysClr val="window" lastClr="FFFFFF"/>
+      </a:lt1>
+      <a:dk2>
+        <a:srgbClr val="0E2841"/>
+      </a:dk2>
+      <a:lt2>
+        <a:srgbClr val="E8E8E8"/>
+      </a:lt2>
+      <a:accent1>
+        <a:srgbClr val="156082"/>
+      </a:accent1>
+      <a:accent2>
+        <a:srgbClr val="E97132"/>
+      </a:accent2>
+      <a:accent3>
+        <a:srgbClr val="196B24"/>
+      </a:accent3>
+      <a:accent4>
+        <a:srgbClr val="0F9ED5"/>
+      </a:accent4>
+      <a:accent5>
+        <a:srgbClr val="A02B93"/>
+      </a:accent5>
+      <a:accent6>
+        <a:srgbClr val="4EA72E"/>
+      </a:accent6>
+      <a:hlink>
+        <a:srgbClr val="467886"/>
+      </a:hlink>
+      <a:folHlink>
+        <a:srgbClr val="96607D"/>
+      </a:folHlink>
+    </a:clrScheme>
+    <a:fontScheme name="Office">
+      <a:majorFont>
+        <a:latin typeface="Aptos Display" panose="02110004020202020204"/>
+        <a:ea typeface=""/>
+        <a:cs typeface=""/>
+        <a:font script="Jpan" typeface="游ゴシック Light"/>
+        <a:font script="Hang" typeface="맑은 고딕"/>
+        <a:font script="Hans" typeface="等线 Light"/>
+        <a:font script="Hant" typeface="新細明體"/>
+        <a:font script="Arab" typeface="Times New Roman"/>
+        <a:font script="Hebr" typeface="Times New Roman"/>
+        <a:font script="Thai" typeface="Angsana New"/>
+        <a:font script="Ethi" typeface="Nyala"/>
+        <a:font script="Beng" typeface="Vrinda"/>
+        <a:font script="Gujr" typeface="Shruti"/>
+        <a:font script="Khmr" typeface="MoolBoran"/>
+        <a:font script="Knda" typeface="Tunga"/>
+        <a:font script="Guru" typeface="Raavi"/>
+        <a:font script="Cans" typeface="Euphemia"/>
+        <a:font script="Cher" typeface="Plantagenet Cherokee"/>
+        <a:font script="Yiii" typeface="Microsoft Yi Baiti"/>
+        <a:font script="Tibt" typeface="Microsoft Himalaya"/>
+        <a:font script="Thaa" typeface="MV Boli"/>
+        <a:font script="Deva" typeface="Mangal"/>
+        <a:font script="Telu" typeface="Gautami"/>
+        <a:font script="Taml" typeface="Latha"/>
+        <a:font script="Syrc" typeface="Estrangelo Edessa"/>
+        <a:font script="Orya" typeface="Kalinga"/>
+        <a:font script="Mlym" typeface="Kartika"/>
+        <a:font script="Laoo" typeface="DokChampa"/>
+        <a:font script="Sinh" typeface="Iskoola Pota"/>
+        <a:font script="Mong" typeface="Mongolian Baiti"/>
+        <a:font script="Viet" typeface="Times New Roman"/>
+        <a:font script="Uigh" typeface="Microsoft Uighur"/>
+        <a:font script="Geor" typeface="Sylfaen"/>
+        <a:font script="Armn" typeface="Arial"/>
+        <a:font script="Bugi" typeface="Leelawadee UI"/>
+        <a:font script="Bopo" typeface="Microsoft JhengHei"/>
+        <a:font script="Java" typeface="Javanese Text"/>
+        <a:font script="Lisu" typeface="Segoe UI"/>
+        <a:font script="Mymr" typeface="Myanmar Text"/>
+        <a:font script="Nkoo" typeface="Ebrima"/>
+        <a:font script="Olck" typeface="Nirmala UI"/>
+        <a:font script="Osma" typeface="Ebrima"/>
+        <a:font script="Phag" typeface="Phagspa"/>
+        <a:font script="Syrn" typeface="Estrangelo Edessa"/>
+        <a:font script="Syrj" typeface="Estrangelo Edessa"/>
+        <a:font script="Syre" typeface="Estrangelo Edessa"/>
+        <a:font script="Sora" typeface="Nirmala UI"/>
+        <a:font script="Tale" typeface="Microsoft Tai Le"/>
+        <a:font script="Talu" typeface="Microsoft New Tai Lue"/>
+        <a:font script="Tfng" typeface="Ebrima"/>
+      </a:majorFont>
+      <a:minorFont>
+        <a:latin typeface="Aptos" panose="02110004020202020204"/>
+        <a:ea typeface=""/>
+        <a:cs typeface=""/>
+        <a:font script="Jpan" typeface="游ゴシック"/>
+        <a:font script="Hang" typeface="맑은 고딕"/>
+        <a:font script="Hans" typeface="等线"/>
+        <a:font script="Hant" typeface="新細明體"/>
+        <a:font script="Arab" typeface="Arial"/>
+        <a:font script="Hebr" typeface="Arial"/>
+        <a:font script="Thai" typeface="Cordia New"/>
+        <a:font script="Ethi" typeface="Nyala"/>
+        <a:font script="Beng" typeface="Vrinda"/>
+        <a:font script="Gujr" typeface="Shruti"/>
+        <a:font script="Khmr" typeface="DaunPenh"/>
+        <a:font script="Knda" typeface="Tunga"/>
+        <a:font script="Guru" typeface="Raavi"/>
+        <a:font script="Cans" typeface="Euphemia"/>
+        <a:font script="Cher" typeface="Plantagenet Cherokee"/>
+        <a:font script="Yiii" typeface="Microsoft Yi Baiti"/>
+        <a:font script="Tibt" typeface="Microsoft Himalaya"/>
+        <a:font script="Thaa" typeface="MV Boli"/>
+        <a:font script="Deva" typeface="Mangal"/>
+        <a:font script="Telu" typeface="Gautami"/>
+        <a:font script="Taml" typeface="Latha"/>
+        <a:font script="Syrc" typeface="Estrangelo Edessa"/>
+        <a:font script="Orya" typeface="Kalinga"/>
+        <a:font script="Mlym" typeface="Kartika"/>
+        <a:font script="Laoo" typeface="DokChampa"/>
+        <a:font script="Sinh" typeface="Iskoola Pota"/>
+        <a:font script="Mong" typeface="Mongolian Baiti"/>
+        <a:font script="Viet" typeface="Arial"/>
+        <a:font script="Uigh" typeface="Microsoft Uighur"/>
+        <a:font script="Geor" typeface="Sylfaen"/>
+        <a:font script="Armn" typeface="Arial"/>
+        <a:font script="Bugi" typeface="Leelawadee UI"/>
+        <a:font script="Bopo" typeface="Microsoft JhengHei"/>
+        <a:font script="Java" typeface="Javanese Text"/>
+        <a:font script="Lisu" typeface="Segoe UI"/>
+        <a:font script="Mymr" typeface="Myanmar Text"/>
+        <a:font script="Nkoo" typeface="Ebrima"/>
+        <a:font script="Olck" typeface="Nirmala UI"/>
+        <a:font script="Osma" typeface="Ebrima"/>
+        <a:font script="Phag" typeface="Phagspa"/>
+        <a:font script="Syrn" typeface="Estrangelo Edessa"/>
+        <a:font script="Syrj" typeface="Estrangelo Edessa"/>
+        <a:font script="Syre" typeface="Estrangelo Edessa"/>
+        <a:font script="Sora" typeface="Nirmala UI"/>
+        <a:font script="Tale" typeface="Microsoft Tai Le"/>
+        <a:font script="Talu" typeface="Microsoft New Tai Lue"/>
+        <a:font script="Tfng" typeface="Ebrima"/>
+      </a:minorFont>
+    </a:fontScheme>
+    <a:fmtScheme name="Office">
+      <a:fillStyleLst>
+        <a:solidFill>
+          <a:schemeClr val="phClr"/>
+        </a:solidFill>
+        <a:gradFill rotWithShape="1">
+          <a:gsLst>
+            <a:gs pos="0">
+              <a:schemeClr val="phClr">
+                <a:lumMod val="110000"/>
+                <a:satMod val="105000"/>
+                <a:tint val="67000"/>
+              </a:schemeClr>
+            </a:gs>
+            <a:gs pos="50000">
+              <a:schemeClr val="phClr">
+                <a:lumMod val="105000"/>
+                <a:satMod val="103000"/>
+                <a:tint val="73000"/>
+              </a:schemeClr>
+            </a:gs>
+            <a:gs pos="100000">
+              <a:schemeClr val="phClr">
+                <a:lumMod val="105000"/>
+                <a:satMod val="109000"/>
+                <a:tint val="81000"/>
+              </a:schemeClr>
+            </a:gs>
+          </a:gsLst>
+          <a:lin ang="5400000" scaled="0"/>
+        </a:gradFill>
+        <a:gradFill rotWithShape="1">
+          <a:gsLst>
+            <a:gs pos="0">
+              <a:schemeClr val="phClr">
+                <a:satMod val="103000"/>
+                <a:lumMod val="102000"/>
+                <a:tint val="94000"/>
+              </a:schemeClr>
+            </a:gs>
+            <a:gs pos="50000">
+              <a:schemeClr val="phClr">
+                <a:satMod val="110000"/>
+                <a:lumMod val="100000"/>
+                <a:shade val="100000"/>
+              </a:schemeClr>
+            </a:gs>
+            <a:gs pos="100000">
+              <a:schemeClr val="phClr">
+                <a:lumMod val="99000"/>
+                <a:satMod val="120000"/>
+                <a:shade val="78000"/>
+              </a:schemeClr>
+            </a:gs>
+          </a:gsLst>
+          <a:lin ang="5400000" scaled="0"/>
+        </a:gradFill>
+      </a:fillStyleLst>
+      <a:lnStyleLst>
+        <a:ln w="12700" cap="flat" cmpd="sng" algn="ctr">
+          <a:solidFill>
+            <a:schemeClr val="phClr"/>
+          </a:solidFill>
+          <a:prstDash val="solid"/>
+          <a:miter lim="800000"/>
+        </a:ln>
+        <a:ln w="19050" cap="flat" cmpd="sng" algn="ctr">
+          <a:solidFill>
+            <a:schemeClr val="phClr"/>
+          </a:solidFill>
+          <a:prstDash val="solid"/>
+          <a:miter lim="800000"/>
+        </a:ln>
+        <a:ln w="25400" cap="flat" cmpd="sng" algn="ctr">
+          <a:solidFill>
+            <a:schemeClr val="phClr"/>
+          </a:solidFill>
+          <a:prstDash val="solid"/>
+          <a:miter lim="800000"/>
+        </a:ln>
+      </a:lnStyleLst>
+      <a:effectStyleLst>
+        <a:effectStyle>
+          <a:effectLst/>
+        </a:effectStyle>
+        <a:effectStyle>
+          <a:effectLst/>
+        </a:effectStyle>
+        <a:effectStyle>
+          <a:effectLst>
+            <a:outerShdw blurRad="57150" dist="19050" dir="5400000" algn="ctr" rotWithShape="0">
+              <a:srgbClr val="000000">
+                <a:alpha val="63000"/>
+              </a:srgbClr>
+            </a:outerShdw>
+          </a:effectLst>
+        </a:effectStyle>
+      </a:effectStyleLst>
+      <a:bgFillStyleLst>
+        <a:solidFill>
+          <a:schemeClr val="phClr"/>
+        </a:solidFill>
+        <a:solidFill>
+          <a:schemeClr val="phClr">
+            <a:tint val="95000"/>
+            <a:satMod val="170000"/>
+          </a:schemeClr>
+        </a:solidFill>
+        <a:gradFill rotWithShape="1">
+          <a:gsLst>
+            <a:gs pos="0">
+              <a:schemeClr val="phClr">
+                <a:tint val="93000"/>
+                <a:satMod val="150000"/>
+                <a:shade val="98000"/>
+                <a:lumMod val="102000"/>
+              </a:schemeClr>
+            </a:gs>
+            <a:gs pos="50000">
+              <a:schemeClr val="phClr">
+                <a:tint val="98000"/>
+                <a:satMod val="130000"/>
+                <a:shade val="90000"/>
+                <a:lumMod val="103000"/>
+              </a:schemeClr>
+            </a:gs>
+            <a:gs pos="100000">
+              <a:schemeClr val="phClr">
+                <a:shade val="63000"/>
+                <a:satMod val="120000"/>
+              </a:schemeClr>
+            </a:gs>
+          </a:gsLst>
+          <a:lin ang="5400000" scaled="0"/>
+        </a:gradFill>
+      </a:bgFillStyleLst>
+    </a:fmtScheme>
+  </a:themeElements>
+  <a:objectDefaults>
+    <a:lnDef>
+      <a:spPr/>
+      <a:bodyPr/>
+      <a:lstStyle/>
+      <a:style>
+        <a:lnRef idx="2">
+          <a:schemeClr val="accent1"/>
+        </a:lnRef>
+        <a:fillRef idx="0">
+          <a:schemeClr val="accent1"/>
+        </a:fillRef>
+        <a:effectRef idx="1">
+          <a:schemeClr val="accent1"/>
+        </a:effectRef>
+        <a:fontRef idx="minor">
+          <a:schemeClr val="tx1"/>
+        </a:fontRef>
+      </a:style>
+    </a:lnDef>
+  </a:objectDefaults>
+  <a:extraClrSchemeLst/>
+  <a:extLst>
+    <a:ext uri="{05A4C25C-085E-4340-85A3-A5531E510DB2}">
+      <thm15:themeFamily xmlns:thm15="http://schemas.microsoft.com/office/thememl/2012/main" name="Office Theme" id="{2E142A2C-CD16-42D6-873A-C26D2A0506FA}" vid="{1BDDFF52-6CD6-40A5-AB3C-68EB2F1E4D0A}"/>
+    </a:ext>
+  </a:extLst>
+</a:theme>
 </file>
</xml_diff>